<commit_message>
release: use explicit demo identities and refresh final materials
</commit_message>
<xml_diff>
--- a/docs/submission/DALIL-FINAL.pptx
+++ b/docs/submission/DALIL-FINAL.pptx
@@ -8492,7 +8492,7 @@
                 <a:ea typeface="Courier New"/>
                 <a:cs typeface="Courier New"/>
               </a:rPr>
-              <a:t>tunnel down -&gt; localhost:8000</a:t>
+              <a:t>tunnel down -&gt; localhost:8002</a:t>
             </a:r>
             <a:endParaRPr sz="1000"/>
           </a:p>
@@ -9072,7 +9072,7 @@
                 <a:ea typeface="Calibri"/>
                 <a:cs typeface="Calibri"/>
               </a:rPr>
-              <a:t>LLM drafts with zero check issues — numbers match cited evidence 20.0%; meaning not measured</a:t>
+              <a:t>Historical LLM drafts, before DEMO labels: zero check issues; numeric consistency 20%; meaning not measured</a:t>
             </a:r>
             <a:endParaRPr sz="1200"/>
           </a:p>
@@ -9164,7 +9164,7 @@
                 <a:ea typeface="Calibri"/>
                 <a:cs typeface="Calibri"/>
               </a:rPr>
-              <a:t>pipeline p50 (no LLM) / experimental LLM draft p50, 4 CPU threads</a:t>
+              <a:t>Historical p50 before DEMO labels: pipeline / LLM draft, 4 CPU threads</a:t>
             </a:r>
             <a:endParaRPr sz="1200"/>
           </a:p>
@@ -10298,7 +10298,7 @@
                 <a:ea typeface="Calibri"/>
                 <a:cs typeface="Calibri"/>
               </a:rPr>
-              <a:t>Synthetic casebook: 3 880 cases, CC0, generator + DATA_CARD committed</a:t>
+              <a:t>Synthetic casebook: 3 080 cases, CC0, generator + DATA_CARD committed</a:t>
             </a:r>
             <a:endParaRPr sz="1350"/>
           </a:p>

</xml_diff>

<commit_message>
Release DALIL V2 Casebook interface with transaction pagination
</commit_message>
<xml_diff>
--- a/docs/submission/DALIL-FINAL.pptx
+++ b/docs/submission/DALIL-FINAL.pptx
@@ -6961,7 +6961,7 @@
                 <a:ea typeface="Calibri"/>
                 <a:cs typeface="Calibri"/>
               </a:rPr>
-              <a:t>llama.cpp :8081</a:t>
+              <a:t>llama.cpp :18081</a:t>
             </a:r>
             <a:endParaRPr sz="1150"/>
           </a:p>
@@ -8492,7 +8492,7 @@
                 <a:ea typeface="Courier New"/>
                 <a:cs typeface="Courier New"/>
               </a:rPr>
-              <a:t>tunnel down -&gt; localhost:8002</a:t>
+              <a:t>tunnel down -&gt; localhost:8012</a:t>
             </a:r>
             <a:endParaRPr sz="1000"/>
           </a:p>

</xml_diff>